<commit_message>
update line colours for metro tunnel opening
</commit_message>
<xml_diff>
--- a/lines.pptx
+++ b/lines.pptx
@@ -14,16 +14,18 @@
     <p:sldId id="265" r:id="rId8"/>
     <p:sldId id="258" r:id="rId9"/>
     <p:sldId id="266" r:id="rId10"/>
-    <p:sldId id="267" r:id="rId11"/>
-    <p:sldId id="268" r:id="rId12"/>
-    <p:sldId id="259" r:id="rId13"/>
-    <p:sldId id="269" r:id="rId14"/>
-    <p:sldId id="270" r:id="rId15"/>
-    <p:sldId id="271" r:id="rId16"/>
-    <p:sldId id="272" r:id="rId17"/>
-    <p:sldId id="260" r:id="rId18"/>
-    <p:sldId id="273" r:id="rId19"/>
-    <p:sldId id="274" r:id="rId20"/>
+    <p:sldId id="275" r:id="rId11"/>
+    <p:sldId id="267" r:id="rId12"/>
+    <p:sldId id="276" r:id="rId13"/>
+    <p:sldId id="268" r:id="rId14"/>
+    <p:sldId id="259" r:id="rId15"/>
+    <p:sldId id="269" r:id="rId16"/>
+    <p:sldId id="270" r:id="rId17"/>
+    <p:sldId id="271" r:id="rId18"/>
+    <p:sldId id="272" r:id="rId19"/>
+    <p:sldId id="260" r:id="rId20"/>
+    <p:sldId id="273" r:id="rId21"/>
+    <p:sldId id="274" r:id="rId22"/>
   </p:sldIdLst>
   <p:sldSz cx="12192000" cy="6858000"/>
   <p:notesSz cx="6858000" cy="9144000"/>
@@ -277,7 +279,7 @@
           <a:p>
             <a:fld id="{6CD1D8C8-0B81-4867-BF7F-A4563C3E5BB4}" type="datetimeFigureOut">
               <a:rPr lang="en-US" smtClean="0"/>
-              <a:t>2024-10-27</a:t>
+              <a:t>1/28/2026</a:t>
             </a:fld>
             <a:endParaRPr lang="en-US"/>
           </a:p>
@@ -475,7 +477,7 @@
           <a:p>
             <a:fld id="{6CD1D8C8-0B81-4867-BF7F-A4563C3E5BB4}" type="datetimeFigureOut">
               <a:rPr lang="en-US" smtClean="0"/>
-              <a:t>2024-10-27</a:t>
+              <a:t>1/28/2026</a:t>
             </a:fld>
             <a:endParaRPr lang="en-US"/>
           </a:p>
@@ -683,7 +685,7 @@
           <a:p>
             <a:fld id="{6CD1D8C8-0B81-4867-BF7F-A4563C3E5BB4}" type="datetimeFigureOut">
               <a:rPr lang="en-US" smtClean="0"/>
-              <a:t>2024-10-27</a:t>
+              <a:t>1/28/2026</a:t>
             </a:fld>
             <a:endParaRPr lang="en-US"/>
           </a:p>
@@ -881,7 +883,7 @@
           <a:p>
             <a:fld id="{6CD1D8C8-0B81-4867-BF7F-A4563C3E5BB4}" type="datetimeFigureOut">
               <a:rPr lang="en-US" smtClean="0"/>
-              <a:t>2024-10-27</a:t>
+              <a:t>1/28/2026</a:t>
             </a:fld>
             <a:endParaRPr lang="en-US"/>
           </a:p>
@@ -1156,7 +1158,7 @@
           <a:p>
             <a:fld id="{6CD1D8C8-0B81-4867-BF7F-A4563C3E5BB4}" type="datetimeFigureOut">
               <a:rPr lang="en-US" smtClean="0"/>
-              <a:t>2024-10-27</a:t>
+              <a:t>1/28/2026</a:t>
             </a:fld>
             <a:endParaRPr lang="en-US"/>
           </a:p>
@@ -1421,7 +1423,7 @@
           <a:p>
             <a:fld id="{6CD1D8C8-0B81-4867-BF7F-A4563C3E5BB4}" type="datetimeFigureOut">
               <a:rPr lang="en-US" smtClean="0"/>
-              <a:t>2024-10-27</a:t>
+              <a:t>1/28/2026</a:t>
             </a:fld>
             <a:endParaRPr lang="en-US"/>
           </a:p>
@@ -1833,7 +1835,7 @@
           <a:p>
             <a:fld id="{6CD1D8C8-0B81-4867-BF7F-A4563C3E5BB4}" type="datetimeFigureOut">
               <a:rPr lang="en-US" smtClean="0"/>
-              <a:t>2024-10-27</a:t>
+              <a:t>1/28/2026</a:t>
             </a:fld>
             <a:endParaRPr lang="en-US"/>
           </a:p>
@@ -1974,7 +1976,7 @@
           <a:p>
             <a:fld id="{6CD1D8C8-0B81-4867-BF7F-A4563C3E5BB4}" type="datetimeFigureOut">
               <a:rPr lang="en-US" smtClean="0"/>
-              <a:t>2024-10-27</a:t>
+              <a:t>1/28/2026</a:t>
             </a:fld>
             <a:endParaRPr lang="en-US"/>
           </a:p>
@@ -2087,7 +2089,7 @@
           <a:p>
             <a:fld id="{6CD1D8C8-0B81-4867-BF7F-A4563C3E5BB4}" type="datetimeFigureOut">
               <a:rPr lang="en-US" smtClean="0"/>
-              <a:t>2024-10-27</a:t>
+              <a:t>1/28/2026</a:t>
             </a:fld>
             <a:endParaRPr lang="en-US"/>
           </a:p>
@@ -2398,7 +2400,7 @@
           <a:p>
             <a:fld id="{6CD1D8C8-0B81-4867-BF7F-A4563C3E5BB4}" type="datetimeFigureOut">
               <a:rPr lang="en-US" smtClean="0"/>
-              <a:t>2024-10-27</a:t>
+              <a:t>1/28/2026</a:t>
             </a:fld>
             <a:endParaRPr lang="en-US"/>
           </a:p>
@@ -2686,7 +2688,7 @@
           <a:p>
             <a:fld id="{6CD1D8C8-0B81-4867-BF7F-A4563C3E5BB4}" type="datetimeFigureOut">
               <a:rPr lang="en-US" smtClean="0"/>
-              <a:t>2024-10-27</a:t>
+              <a:t>1/28/2026</a:t>
             </a:fld>
             <a:endParaRPr lang="en-US"/>
           </a:p>
@@ -2927,7 +2929,7 @@
           <a:p>
             <a:fld id="{6CD1D8C8-0B81-4867-BF7F-A4563C3E5BB4}" type="datetimeFigureOut">
               <a:rPr lang="en-US" smtClean="0"/>
-              <a:t>2024-10-27</a:t>
+              <a:t>1/28/2026</a:t>
             </a:fld>
             <a:endParaRPr lang="en-US"/>
           </a:p>
@@ -3420,6 +3422,97 @@
         <p:cNvPr id="1" name="">
           <a:extLst>
             <a:ext uri="{FF2B5EF4-FFF2-40B4-BE49-F238E27FC236}">
+              <a16:creationId xmlns:a16="http://schemas.microsoft.com/office/drawing/2014/main" id="{AB894BDB-E362-0D07-402E-3412EAB0C94F}"/>
+            </a:ext>
+          </a:extLst>
+        </p:cNvPr>
+        <p:cNvGrpSpPr/>
+        <p:nvPr/>
+      </p:nvGrpSpPr>
+      <p:grpSpPr>
+        <a:xfrm>
+          <a:off x="0" y="0"/>
+          <a:ext cx="0" cy="0"/>
+          <a:chOff x="0" y="0"/>
+          <a:chExt cx="0" cy="0"/>
+        </a:xfrm>
+      </p:grpSpPr>
+      <p:sp>
+        <p:nvSpPr>
+          <p:cNvPr id="2" name="Rectangle: Rounded Corners 1">
+            <a:extLst>
+              <a:ext uri="{FF2B5EF4-FFF2-40B4-BE49-F238E27FC236}">
+                <a16:creationId xmlns:a16="http://schemas.microsoft.com/office/drawing/2014/main" id="{EC6702DC-3BAB-D408-15F2-0EE2B680BC0F}"/>
+              </a:ext>
+            </a:extLst>
+          </p:cNvPr>
+          <p:cNvSpPr/>
+          <p:nvPr/>
+        </p:nvSpPr>
+        <p:spPr>
+          <a:xfrm>
+            <a:off x="-1" y="1328057"/>
+            <a:ext cx="5252645" cy="1230858"/>
+          </a:xfrm>
+          <a:prstGeom prst="roundRect">
+            <a:avLst/>
+          </a:prstGeom>
+          <a:solidFill>
+            <a:srgbClr val="F17FB1"/>
+          </a:solidFill>
+        </p:spPr>
+        <p:style>
+          <a:lnRef idx="2">
+            <a:schemeClr val="accent1">
+              <a:shade val="15000"/>
+            </a:schemeClr>
+          </a:lnRef>
+          <a:fillRef idx="1">
+            <a:schemeClr val="accent1"/>
+          </a:fillRef>
+          <a:effectRef idx="0">
+            <a:schemeClr val="accent1"/>
+          </a:effectRef>
+          <a:fontRef idx="minor">
+            <a:schemeClr val="lt1"/>
+          </a:fontRef>
+        </p:style>
+        <p:txBody>
+          <a:bodyPr rtlCol="0" anchor="ctr"/>
+          <a:lstStyle/>
+          <a:p>
+            <a:pPr algn="ctr"/>
+            <a:r>
+              <a:rPr lang="en-US" sz="6600" dirty="0">
+                <a:latin typeface="Arial" panose="020B0604020202020204" pitchFamily="34" charset="0"/>
+                <a:cs typeface="Arial" panose="020B0604020202020204" pitchFamily="34" charset="0"/>
+              </a:rPr>
+              <a:t>Williamstown</a:t>
+            </a:r>
+          </a:p>
+        </p:txBody>
+      </p:sp>
+    </p:spTree>
+    <p:extLst>
+      <p:ext uri="{BB962C8B-B14F-4D97-AF65-F5344CB8AC3E}">
+        <p14:creationId xmlns:p14="http://schemas.microsoft.com/office/powerpoint/2010/main" val="635404039"/>
+      </p:ext>
+    </p:extLst>
+  </p:cSld>
+  <p:clrMapOvr>
+    <a:masterClrMapping/>
+  </p:clrMapOvr>
+</p:sld>
+</file>
+
+<file path=ppt/slides/slide11.xml><?xml version="1.0" encoding="utf-8"?>
+<p:sld xmlns:a="http://schemas.openxmlformats.org/drawingml/2006/main" xmlns:r="http://schemas.openxmlformats.org/officeDocument/2006/relationships" xmlns:p="http://schemas.openxmlformats.org/presentationml/2006/main">
+  <p:cSld>
+    <p:spTree>
+      <p:nvGrpSpPr>
+        <p:cNvPr id="1" name="">
+          <a:extLst>
+            <a:ext uri="{FF2B5EF4-FFF2-40B4-BE49-F238E27FC236}">
               <a16:creationId xmlns:a16="http://schemas.microsoft.com/office/drawing/2014/main" id="{671DEDE4-7D57-1609-0683-D8B542899E62}"/>
             </a:ext>
           </a:extLst>
@@ -3503,7 +3596,98 @@
 </p:sld>
 </file>
 
-<file path=ppt/slides/slide11.xml><?xml version="1.0" encoding="utf-8"?>
+<file path=ppt/slides/slide12.xml><?xml version="1.0" encoding="utf-8"?>
+<p:sld xmlns:a="http://schemas.openxmlformats.org/drawingml/2006/main" xmlns:r="http://schemas.openxmlformats.org/officeDocument/2006/relationships" xmlns:p="http://schemas.openxmlformats.org/presentationml/2006/main">
+  <p:cSld>
+    <p:spTree>
+      <p:nvGrpSpPr>
+        <p:cNvPr id="1" name="">
+          <a:extLst>
+            <a:ext uri="{FF2B5EF4-FFF2-40B4-BE49-F238E27FC236}">
+              <a16:creationId xmlns:a16="http://schemas.microsoft.com/office/drawing/2014/main" id="{36ECA3D9-56B3-5CD5-423E-D5B3B5A7C7B3}"/>
+            </a:ext>
+          </a:extLst>
+        </p:cNvPr>
+        <p:cNvGrpSpPr/>
+        <p:nvPr/>
+      </p:nvGrpSpPr>
+      <p:grpSpPr>
+        <a:xfrm>
+          <a:off x="0" y="0"/>
+          <a:ext cx="0" cy="0"/>
+          <a:chOff x="0" y="0"/>
+          <a:chExt cx="0" cy="0"/>
+        </a:xfrm>
+      </p:grpSpPr>
+      <p:sp>
+        <p:nvSpPr>
+          <p:cNvPr id="3" name="Rectangle: Rounded Corners 2">
+            <a:extLst>
+              <a:ext uri="{FF2B5EF4-FFF2-40B4-BE49-F238E27FC236}">
+                <a16:creationId xmlns:a16="http://schemas.microsoft.com/office/drawing/2014/main" id="{FF9C5E38-6BBF-89E1-E08D-0DFF56EF9B35}"/>
+              </a:ext>
+            </a:extLst>
+          </p:cNvPr>
+          <p:cNvSpPr/>
+          <p:nvPr/>
+        </p:nvSpPr>
+        <p:spPr>
+          <a:xfrm>
+            <a:off x="-2" y="2656114"/>
+            <a:ext cx="3719479" cy="1230858"/>
+          </a:xfrm>
+          <a:prstGeom prst="roundRect">
+            <a:avLst/>
+          </a:prstGeom>
+          <a:solidFill>
+            <a:srgbClr val="F17FB1"/>
+          </a:solidFill>
+        </p:spPr>
+        <p:style>
+          <a:lnRef idx="2">
+            <a:schemeClr val="accent1">
+              <a:shade val="15000"/>
+            </a:schemeClr>
+          </a:lnRef>
+          <a:fillRef idx="1">
+            <a:schemeClr val="accent1"/>
+          </a:fillRef>
+          <a:effectRef idx="0">
+            <a:schemeClr val="accent1"/>
+          </a:effectRef>
+          <a:fontRef idx="minor">
+            <a:schemeClr val="lt1"/>
+          </a:fontRef>
+        </p:style>
+        <p:txBody>
+          <a:bodyPr rtlCol="0" anchor="ctr"/>
+          <a:lstStyle/>
+          <a:p>
+            <a:pPr algn="ctr"/>
+            <a:r>
+              <a:rPr lang="en-US" sz="6600" dirty="0">
+                <a:latin typeface="Arial" panose="020B0604020202020204" pitchFamily="34" charset="0"/>
+                <a:cs typeface="Arial" panose="020B0604020202020204" pitchFamily="34" charset="0"/>
+              </a:rPr>
+              <a:t>Werribee</a:t>
+            </a:r>
+          </a:p>
+        </p:txBody>
+      </p:sp>
+    </p:spTree>
+    <p:extLst>
+      <p:ext uri="{BB962C8B-B14F-4D97-AF65-F5344CB8AC3E}">
+        <p14:creationId xmlns:p14="http://schemas.microsoft.com/office/powerpoint/2010/main" val="581619592"/>
+      </p:ext>
+    </p:extLst>
+  </p:cSld>
+  <p:clrMapOvr>
+    <a:masterClrMapping/>
+  </p:clrMapOvr>
+</p:sld>
+</file>
+
+<file path=ppt/slides/slide13.xml><?xml version="1.0" encoding="utf-8"?>
 <p:sld xmlns:a="http://schemas.openxmlformats.org/drawingml/2006/main" xmlns:r="http://schemas.openxmlformats.org/officeDocument/2006/relationships" xmlns:p="http://schemas.openxmlformats.org/presentationml/2006/main">
   <p:cSld>
     <p:spTree>
@@ -3594,7 +3778,7 @@
 </p:sld>
 </file>
 
-<file path=ppt/slides/slide12.xml><?xml version="1.0" encoding="utf-8"?>
+<file path=ppt/slides/slide14.xml><?xml version="1.0" encoding="utf-8"?>
 <p:sld xmlns:a="http://schemas.openxmlformats.org/drawingml/2006/main" xmlns:r="http://schemas.openxmlformats.org/officeDocument/2006/relationships" xmlns:p="http://schemas.openxmlformats.org/presentationml/2006/main">
   <p:cSld>
     <p:spTree>
@@ -3689,7 +3873,7 @@
 </p:sld>
 </file>
 
-<file path=ppt/slides/slide13.xml><?xml version="1.0" encoding="utf-8"?>
+<file path=ppt/slides/slide15.xml><?xml version="1.0" encoding="utf-8"?>
 <p:sld xmlns:a="http://schemas.openxmlformats.org/drawingml/2006/main" xmlns:r="http://schemas.openxmlformats.org/officeDocument/2006/relationships" xmlns:p="http://schemas.openxmlformats.org/presentationml/2006/main">
   <p:cSld>
     <p:spTree>
@@ -3780,7 +3964,7 @@
 </p:sld>
 </file>
 
-<file path=ppt/slides/slide14.xml><?xml version="1.0" encoding="utf-8"?>
+<file path=ppt/slides/slide16.xml><?xml version="1.0" encoding="utf-8"?>
 <p:sld xmlns:a="http://schemas.openxmlformats.org/drawingml/2006/main" xmlns:r="http://schemas.openxmlformats.org/officeDocument/2006/relationships" xmlns:p="http://schemas.openxmlformats.org/presentationml/2006/main">
   <p:cSld>
     <p:spTree>
@@ -3871,7 +4055,7 @@
 </p:sld>
 </file>
 
-<file path=ppt/slides/slide15.xml><?xml version="1.0" encoding="utf-8"?>
+<file path=ppt/slides/slide17.xml><?xml version="1.0" encoding="utf-8"?>
 <p:sld xmlns:a="http://schemas.openxmlformats.org/drawingml/2006/main" xmlns:r="http://schemas.openxmlformats.org/officeDocument/2006/relationships" xmlns:p="http://schemas.openxmlformats.org/presentationml/2006/main">
   <p:cSld>
     <p:spTree>
@@ -3962,7 +4146,7 @@
 </p:sld>
 </file>
 
-<file path=ppt/slides/slide16.xml><?xml version="1.0" encoding="utf-8"?>
+<file path=ppt/slides/slide18.xml><?xml version="1.0" encoding="utf-8"?>
 <p:sld xmlns:a="http://schemas.openxmlformats.org/drawingml/2006/main" xmlns:r="http://schemas.openxmlformats.org/officeDocument/2006/relationships" xmlns:p="http://schemas.openxmlformats.org/presentationml/2006/main">
   <p:cSld>
     <p:spTree>
@@ -4057,7 +4241,7 @@
 </p:sld>
 </file>
 
-<file path=ppt/slides/slide17.xml><?xml version="1.0" encoding="utf-8"?>
+<file path=ppt/slides/slide19.xml><?xml version="1.0" encoding="utf-8"?>
 <p:sld xmlns:a="http://schemas.openxmlformats.org/drawingml/2006/main" xmlns:r="http://schemas.openxmlformats.org/officeDocument/2006/relationships" xmlns:p="http://schemas.openxmlformats.org/presentationml/2006/main" showMasterSp="0">
   <p:cSld>
     <p:bg>
@@ -4158,7 +4342,98 @@
 </p:sld>
 </file>
 
-<file path=ppt/slides/slide18.xml><?xml version="1.0" encoding="utf-8"?>
+<file path=ppt/slides/slide2.xml><?xml version="1.0" encoding="utf-8"?>
+<p:sld xmlns:a="http://schemas.openxmlformats.org/drawingml/2006/main" xmlns:r="http://schemas.openxmlformats.org/officeDocument/2006/relationships" xmlns:p="http://schemas.openxmlformats.org/presentationml/2006/main">
+  <p:cSld>
+    <p:spTree>
+      <p:nvGrpSpPr>
+        <p:cNvPr id="1" name="">
+          <a:extLst>
+            <a:ext uri="{FF2B5EF4-FFF2-40B4-BE49-F238E27FC236}">
+              <a16:creationId xmlns:a16="http://schemas.microsoft.com/office/drawing/2014/main" id="{880421E4-1543-8886-7C15-127A6F0848A1}"/>
+            </a:ext>
+          </a:extLst>
+        </p:cNvPr>
+        <p:cNvGrpSpPr/>
+        <p:nvPr/>
+      </p:nvGrpSpPr>
+      <p:grpSpPr>
+        <a:xfrm>
+          <a:off x="0" y="0"/>
+          <a:ext cx="0" cy="0"/>
+          <a:chOff x="0" y="0"/>
+          <a:chExt cx="0" cy="0"/>
+        </a:xfrm>
+      </p:grpSpPr>
+      <p:sp>
+        <p:nvSpPr>
+          <p:cNvPr id="5" name="Rectangle: Rounded Corners 4">
+            <a:extLst>
+              <a:ext uri="{FF2B5EF4-FFF2-40B4-BE49-F238E27FC236}">
+                <a16:creationId xmlns:a16="http://schemas.microsoft.com/office/drawing/2014/main" id="{6BF4E7AB-D02A-CDCE-B638-895666F8ADDE}"/>
+              </a:ext>
+            </a:extLst>
+          </p:cNvPr>
+          <p:cNvSpPr/>
+          <p:nvPr/>
+        </p:nvSpPr>
+        <p:spPr>
+          <a:xfrm>
+            <a:off x="-1" y="1319283"/>
+            <a:ext cx="3636975" cy="1230858"/>
+          </a:xfrm>
+          <a:prstGeom prst="roundRect">
+            <a:avLst/>
+          </a:prstGeom>
+          <a:solidFill>
+            <a:srgbClr val="01518A"/>
+          </a:solidFill>
+        </p:spPr>
+        <p:style>
+          <a:lnRef idx="2">
+            <a:schemeClr val="accent1">
+              <a:shade val="15000"/>
+            </a:schemeClr>
+          </a:lnRef>
+          <a:fillRef idx="1">
+            <a:schemeClr val="accent1"/>
+          </a:fillRef>
+          <a:effectRef idx="0">
+            <a:schemeClr val="accent1"/>
+          </a:effectRef>
+          <a:fontRef idx="minor">
+            <a:schemeClr val="lt1"/>
+          </a:fontRef>
+        </p:style>
+        <p:txBody>
+          <a:bodyPr rtlCol="0" anchor="ctr"/>
+          <a:lstStyle/>
+          <a:p>
+            <a:pPr algn="ctr"/>
+            <a:r>
+              <a:rPr lang="en-US" sz="6600" dirty="0">
+                <a:latin typeface="Arial" panose="020B0604020202020204" pitchFamily="34" charset="0"/>
+                <a:cs typeface="Arial" panose="020B0604020202020204" pitchFamily="34" charset="0"/>
+              </a:rPr>
+              <a:t>Belgrave</a:t>
+            </a:r>
+          </a:p>
+        </p:txBody>
+      </p:sp>
+    </p:spTree>
+    <p:extLst>
+      <p:ext uri="{BB962C8B-B14F-4D97-AF65-F5344CB8AC3E}">
+        <p14:creationId xmlns:p14="http://schemas.microsoft.com/office/powerpoint/2010/main" val="1129601660"/>
+      </p:ext>
+    </p:extLst>
+  </p:cSld>
+  <p:clrMapOvr>
+    <a:masterClrMapping/>
+  </p:clrMapOvr>
+</p:sld>
+</file>
+
+<file path=ppt/slides/slide20.xml><?xml version="1.0" encoding="utf-8"?>
 <p:sld xmlns:a="http://schemas.openxmlformats.org/drawingml/2006/main" xmlns:r="http://schemas.openxmlformats.org/officeDocument/2006/relationships" xmlns:p="http://schemas.openxmlformats.org/presentationml/2006/main">
   <p:cSld>
     <p:spTree>
@@ -4249,7 +4524,7 @@
 </p:sld>
 </file>
 
-<file path=ppt/slides/slide19.xml><?xml version="1.0" encoding="utf-8"?>
+<file path=ppt/slides/slide21.xml><?xml version="1.0" encoding="utf-8"?>
 <p:sld xmlns:a="http://schemas.openxmlformats.org/drawingml/2006/main" xmlns:r="http://schemas.openxmlformats.org/officeDocument/2006/relationships" xmlns:p="http://schemas.openxmlformats.org/presentationml/2006/main">
   <p:cSld>
     <p:spTree>
@@ -4331,97 +4606,6 @@
     <p:extLst>
       <p:ext uri="{BB962C8B-B14F-4D97-AF65-F5344CB8AC3E}">
         <p14:creationId xmlns:p14="http://schemas.microsoft.com/office/powerpoint/2010/main" val="3488651827"/>
-      </p:ext>
-    </p:extLst>
-  </p:cSld>
-  <p:clrMapOvr>
-    <a:masterClrMapping/>
-  </p:clrMapOvr>
-</p:sld>
-</file>
-
-<file path=ppt/slides/slide2.xml><?xml version="1.0" encoding="utf-8"?>
-<p:sld xmlns:a="http://schemas.openxmlformats.org/drawingml/2006/main" xmlns:r="http://schemas.openxmlformats.org/officeDocument/2006/relationships" xmlns:p="http://schemas.openxmlformats.org/presentationml/2006/main">
-  <p:cSld>
-    <p:spTree>
-      <p:nvGrpSpPr>
-        <p:cNvPr id="1" name="">
-          <a:extLst>
-            <a:ext uri="{FF2B5EF4-FFF2-40B4-BE49-F238E27FC236}">
-              <a16:creationId xmlns:a16="http://schemas.microsoft.com/office/drawing/2014/main" id="{880421E4-1543-8886-7C15-127A6F0848A1}"/>
-            </a:ext>
-          </a:extLst>
-        </p:cNvPr>
-        <p:cNvGrpSpPr/>
-        <p:nvPr/>
-      </p:nvGrpSpPr>
-      <p:grpSpPr>
-        <a:xfrm>
-          <a:off x="0" y="0"/>
-          <a:ext cx="0" cy="0"/>
-          <a:chOff x="0" y="0"/>
-          <a:chExt cx="0" cy="0"/>
-        </a:xfrm>
-      </p:grpSpPr>
-      <p:sp>
-        <p:nvSpPr>
-          <p:cNvPr id="5" name="Rectangle: Rounded Corners 4">
-            <a:extLst>
-              <a:ext uri="{FF2B5EF4-FFF2-40B4-BE49-F238E27FC236}">
-                <a16:creationId xmlns:a16="http://schemas.microsoft.com/office/drawing/2014/main" id="{6BF4E7AB-D02A-CDCE-B638-895666F8ADDE}"/>
-              </a:ext>
-            </a:extLst>
-          </p:cNvPr>
-          <p:cNvSpPr/>
-          <p:nvPr/>
-        </p:nvSpPr>
-        <p:spPr>
-          <a:xfrm>
-            <a:off x="-1" y="1319283"/>
-            <a:ext cx="3636975" cy="1230858"/>
-          </a:xfrm>
-          <a:prstGeom prst="roundRect">
-            <a:avLst/>
-          </a:prstGeom>
-          <a:solidFill>
-            <a:srgbClr val="01518A"/>
-          </a:solidFill>
-        </p:spPr>
-        <p:style>
-          <a:lnRef idx="2">
-            <a:schemeClr val="accent1">
-              <a:shade val="15000"/>
-            </a:schemeClr>
-          </a:lnRef>
-          <a:fillRef idx="1">
-            <a:schemeClr val="accent1"/>
-          </a:fillRef>
-          <a:effectRef idx="0">
-            <a:schemeClr val="accent1"/>
-          </a:effectRef>
-          <a:fontRef idx="minor">
-            <a:schemeClr val="lt1"/>
-          </a:fontRef>
-        </p:style>
-        <p:txBody>
-          <a:bodyPr rtlCol="0" anchor="ctr"/>
-          <a:lstStyle/>
-          <a:p>
-            <a:pPr algn="ctr"/>
-            <a:r>
-              <a:rPr lang="en-US" sz="6600" dirty="0">
-                <a:latin typeface="Arial" panose="020B0604020202020204" pitchFamily="34" charset="0"/>
-                <a:cs typeface="Arial" panose="020B0604020202020204" pitchFamily="34" charset="0"/>
-              </a:rPr>
-              <a:t>Belgrave</a:t>
-            </a:r>
-          </a:p>
-        </p:txBody>
-      </p:sp>
-    </p:spTree>
-    <p:extLst>
-      <p:ext uri="{BB962C8B-B14F-4D97-AF65-F5344CB8AC3E}">
-        <p14:creationId xmlns:p14="http://schemas.microsoft.com/office/powerpoint/2010/main" val="1129601660"/>
       </p:ext>
     </p:extLst>
   </p:cSld>

</xml_diff>

<commit_message>
Revert "update line colours for metro tunnel opening"
This reverts commit 0da940f81d716ea3d427d96b47148eb035c5a980.
</commit_message>
<xml_diff>
--- a/lines.pptx
+++ b/lines.pptx
@@ -14,18 +14,16 @@
     <p:sldId id="265" r:id="rId8"/>
     <p:sldId id="258" r:id="rId9"/>
     <p:sldId id="266" r:id="rId10"/>
-    <p:sldId id="275" r:id="rId11"/>
-    <p:sldId id="267" r:id="rId12"/>
-    <p:sldId id="276" r:id="rId13"/>
-    <p:sldId id="268" r:id="rId14"/>
-    <p:sldId id="259" r:id="rId15"/>
-    <p:sldId id="269" r:id="rId16"/>
-    <p:sldId id="270" r:id="rId17"/>
-    <p:sldId id="271" r:id="rId18"/>
-    <p:sldId id="272" r:id="rId19"/>
-    <p:sldId id="260" r:id="rId20"/>
-    <p:sldId id="273" r:id="rId21"/>
-    <p:sldId id="274" r:id="rId22"/>
+    <p:sldId id="267" r:id="rId11"/>
+    <p:sldId id="268" r:id="rId12"/>
+    <p:sldId id="259" r:id="rId13"/>
+    <p:sldId id="269" r:id="rId14"/>
+    <p:sldId id="270" r:id="rId15"/>
+    <p:sldId id="271" r:id="rId16"/>
+    <p:sldId id="272" r:id="rId17"/>
+    <p:sldId id="260" r:id="rId18"/>
+    <p:sldId id="273" r:id="rId19"/>
+    <p:sldId id="274" r:id="rId20"/>
   </p:sldIdLst>
   <p:sldSz cx="12192000" cy="6858000"/>
   <p:notesSz cx="6858000" cy="9144000"/>
@@ -279,7 +277,7 @@
           <a:p>
             <a:fld id="{6CD1D8C8-0B81-4867-BF7F-A4563C3E5BB4}" type="datetimeFigureOut">
               <a:rPr lang="en-US" smtClean="0"/>
-              <a:t>1/28/2026</a:t>
+              <a:t>2024-10-27</a:t>
             </a:fld>
             <a:endParaRPr lang="en-US"/>
           </a:p>
@@ -477,7 +475,7 @@
           <a:p>
             <a:fld id="{6CD1D8C8-0B81-4867-BF7F-A4563C3E5BB4}" type="datetimeFigureOut">
               <a:rPr lang="en-US" smtClean="0"/>
-              <a:t>1/28/2026</a:t>
+              <a:t>2024-10-27</a:t>
             </a:fld>
             <a:endParaRPr lang="en-US"/>
           </a:p>
@@ -685,7 +683,7 @@
           <a:p>
             <a:fld id="{6CD1D8C8-0B81-4867-BF7F-A4563C3E5BB4}" type="datetimeFigureOut">
               <a:rPr lang="en-US" smtClean="0"/>
-              <a:t>1/28/2026</a:t>
+              <a:t>2024-10-27</a:t>
             </a:fld>
             <a:endParaRPr lang="en-US"/>
           </a:p>
@@ -883,7 +881,7 @@
           <a:p>
             <a:fld id="{6CD1D8C8-0B81-4867-BF7F-A4563C3E5BB4}" type="datetimeFigureOut">
               <a:rPr lang="en-US" smtClean="0"/>
-              <a:t>1/28/2026</a:t>
+              <a:t>2024-10-27</a:t>
             </a:fld>
             <a:endParaRPr lang="en-US"/>
           </a:p>
@@ -1158,7 +1156,7 @@
           <a:p>
             <a:fld id="{6CD1D8C8-0B81-4867-BF7F-A4563C3E5BB4}" type="datetimeFigureOut">
               <a:rPr lang="en-US" smtClean="0"/>
-              <a:t>1/28/2026</a:t>
+              <a:t>2024-10-27</a:t>
             </a:fld>
             <a:endParaRPr lang="en-US"/>
           </a:p>
@@ -1423,7 +1421,7 @@
           <a:p>
             <a:fld id="{6CD1D8C8-0B81-4867-BF7F-A4563C3E5BB4}" type="datetimeFigureOut">
               <a:rPr lang="en-US" smtClean="0"/>
-              <a:t>1/28/2026</a:t>
+              <a:t>2024-10-27</a:t>
             </a:fld>
             <a:endParaRPr lang="en-US"/>
           </a:p>
@@ -1835,7 +1833,7 @@
           <a:p>
             <a:fld id="{6CD1D8C8-0B81-4867-BF7F-A4563C3E5BB4}" type="datetimeFigureOut">
               <a:rPr lang="en-US" smtClean="0"/>
-              <a:t>1/28/2026</a:t>
+              <a:t>2024-10-27</a:t>
             </a:fld>
             <a:endParaRPr lang="en-US"/>
           </a:p>
@@ -1976,7 +1974,7 @@
           <a:p>
             <a:fld id="{6CD1D8C8-0B81-4867-BF7F-A4563C3E5BB4}" type="datetimeFigureOut">
               <a:rPr lang="en-US" smtClean="0"/>
-              <a:t>1/28/2026</a:t>
+              <a:t>2024-10-27</a:t>
             </a:fld>
             <a:endParaRPr lang="en-US"/>
           </a:p>
@@ -2089,7 +2087,7 @@
           <a:p>
             <a:fld id="{6CD1D8C8-0B81-4867-BF7F-A4563C3E5BB4}" type="datetimeFigureOut">
               <a:rPr lang="en-US" smtClean="0"/>
-              <a:t>1/28/2026</a:t>
+              <a:t>2024-10-27</a:t>
             </a:fld>
             <a:endParaRPr lang="en-US"/>
           </a:p>
@@ -2400,7 +2398,7 @@
           <a:p>
             <a:fld id="{6CD1D8C8-0B81-4867-BF7F-A4563C3E5BB4}" type="datetimeFigureOut">
               <a:rPr lang="en-US" smtClean="0"/>
-              <a:t>1/28/2026</a:t>
+              <a:t>2024-10-27</a:t>
             </a:fld>
             <a:endParaRPr lang="en-US"/>
           </a:p>
@@ -2688,7 +2686,7 @@
           <a:p>
             <a:fld id="{6CD1D8C8-0B81-4867-BF7F-A4563C3E5BB4}" type="datetimeFigureOut">
               <a:rPr lang="en-US" smtClean="0"/>
-              <a:t>1/28/2026</a:t>
+              <a:t>2024-10-27</a:t>
             </a:fld>
             <a:endParaRPr lang="en-US"/>
           </a:p>
@@ -2929,7 +2927,7 @@
           <a:p>
             <a:fld id="{6CD1D8C8-0B81-4867-BF7F-A4563C3E5BB4}" type="datetimeFigureOut">
               <a:rPr lang="en-US" smtClean="0"/>
-              <a:t>1/28/2026</a:t>
+              <a:t>2024-10-27</a:t>
             </a:fld>
             <a:endParaRPr lang="en-US"/>
           </a:p>
@@ -3422,97 +3420,6 @@
         <p:cNvPr id="1" name="">
           <a:extLst>
             <a:ext uri="{FF2B5EF4-FFF2-40B4-BE49-F238E27FC236}">
-              <a16:creationId xmlns:a16="http://schemas.microsoft.com/office/drawing/2014/main" id="{AB894BDB-E362-0D07-402E-3412EAB0C94F}"/>
-            </a:ext>
-          </a:extLst>
-        </p:cNvPr>
-        <p:cNvGrpSpPr/>
-        <p:nvPr/>
-      </p:nvGrpSpPr>
-      <p:grpSpPr>
-        <a:xfrm>
-          <a:off x="0" y="0"/>
-          <a:ext cx="0" cy="0"/>
-          <a:chOff x="0" y="0"/>
-          <a:chExt cx="0" cy="0"/>
-        </a:xfrm>
-      </p:grpSpPr>
-      <p:sp>
-        <p:nvSpPr>
-          <p:cNvPr id="2" name="Rectangle: Rounded Corners 1">
-            <a:extLst>
-              <a:ext uri="{FF2B5EF4-FFF2-40B4-BE49-F238E27FC236}">
-                <a16:creationId xmlns:a16="http://schemas.microsoft.com/office/drawing/2014/main" id="{EC6702DC-3BAB-D408-15F2-0EE2B680BC0F}"/>
-              </a:ext>
-            </a:extLst>
-          </p:cNvPr>
-          <p:cNvSpPr/>
-          <p:nvPr/>
-        </p:nvSpPr>
-        <p:spPr>
-          <a:xfrm>
-            <a:off x="-1" y="1328057"/>
-            <a:ext cx="5252645" cy="1230858"/>
-          </a:xfrm>
-          <a:prstGeom prst="roundRect">
-            <a:avLst/>
-          </a:prstGeom>
-          <a:solidFill>
-            <a:srgbClr val="F17FB1"/>
-          </a:solidFill>
-        </p:spPr>
-        <p:style>
-          <a:lnRef idx="2">
-            <a:schemeClr val="accent1">
-              <a:shade val="15000"/>
-            </a:schemeClr>
-          </a:lnRef>
-          <a:fillRef idx="1">
-            <a:schemeClr val="accent1"/>
-          </a:fillRef>
-          <a:effectRef idx="0">
-            <a:schemeClr val="accent1"/>
-          </a:effectRef>
-          <a:fontRef idx="minor">
-            <a:schemeClr val="lt1"/>
-          </a:fontRef>
-        </p:style>
-        <p:txBody>
-          <a:bodyPr rtlCol="0" anchor="ctr"/>
-          <a:lstStyle/>
-          <a:p>
-            <a:pPr algn="ctr"/>
-            <a:r>
-              <a:rPr lang="en-US" sz="6600" dirty="0">
-                <a:latin typeface="Arial" panose="020B0604020202020204" pitchFamily="34" charset="0"/>
-                <a:cs typeface="Arial" panose="020B0604020202020204" pitchFamily="34" charset="0"/>
-              </a:rPr>
-              <a:t>Williamstown</a:t>
-            </a:r>
-          </a:p>
-        </p:txBody>
-      </p:sp>
-    </p:spTree>
-    <p:extLst>
-      <p:ext uri="{BB962C8B-B14F-4D97-AF65-F5344CB8AC3E}">
-        <p14:creationId xmlns:p14="http://schemas.microsoft.com/office/powerpoint/2010/main" val="635404039"/>
-      </p:ext>
-    </p:extLst>
-  </p:cSld>
-  <p:clrMapOvr>
-    <a:masterClrMapping/>
-  </p:clrMapOvr>
-</p:sld>
-</file>
-
-<file path=ppt/slides/slide11.xml><?xml version="1.0" encoding="utf-8"?>
-<p:sld xmlns:a="http://schemas.openxmlformats.org/drawingml/2006/main" xmlns:r="http://schemas.openxmlformats.org/officeDocument/2006/relationships" xmlns:p="http://schemas.openxmlformats.org/presentationml/2006/main">
-  <p:cSld>
-    <p:spTree>
-      <p:nvGrpSpPr>
-        <p:cNvPr id="1" name="">
-          <a:extLst>
-            <a:ext uri="{FF2B5EF4-FFF2-40B4-BE49-F238E27FC236}">
               <a16:creationId xmlns:a16="http://schemas.microsoft.com/office/drawing/2014/main" id="{671DEDE4-7D57-1609-0683-D8B542899E62}"/>
             </a:ext>
           </a:extLst>
@@ -3596,98 +3503,7 @@
 </p:sld>
 </file>
 
-<file path=ppt/slides/slide12.xml><?xml version="1.0" encoding="utf-8"?>
-<p:sld xmlns:a="http://schemas.openxmlformats.org/drawingml/2006/main" xmlns:r="http://schemas.openxmlformats.org/officeDocument/2006/relationships" xmlns:p="http://schemas.openxmlformats.org/presentationml/2006/main">
-  <p:cSld>
-    <p:spTree>
-      <p:nvGrpSpPr>
-        <p:cNvPr id="1" name="">
-          <a:extLst>
-            <a:ext uri="{FF2B5EF4-FFF2-40B4-BE49-F238E27FC236}">
-              <a16:creationId xmlns:a16="http://schemas.microsoft.com/office/drawing/2014/main" id="{36ECA3D9-56B3-5CD5-423E-D5B3B5A7C7B3}"/>
-            </a:ext>
-          </a:extLst>
-        </p:cNvPr>
-        <p:cNvGrpSpPr/>
-        <p:nvPr/>
-      </p:nvGrpSpPr>
-      <p:grpSpPr>
-        <a:xfrm>
-          <a:off x="0" y="0"/>
-          <a:ext cx="0" cy="0"/>
-          <a:chOff x="0" y="0"/>
-          <a:chExt cx="0" cy="0"/>
-        </a:xfrm>
-      </p:grpSpPr>
-      <p:sp>
-        <p:nvSpPr>
-          <p:cNvPr id="3" name="Rectangle: Rounded Corners 2">
-            <a:extLst>
-              <a:ext uri="{FF2B5EF4-FFF2-40B4-BE49-F238E27FC236}">
-                <a16:creationId xmlns:a16="http://schemas.microsoft.com/office/drawing/2014/main" id="{FF9C5E38-6BBF-89E1-E08D-0DFF56EF9B35}"/>
-              </a:ext>
-            </a:extLst>
-          </p:cNvPr>
-          <p:cNvSpPr/>
-          <p:nvPr/>
-        </p:nvSpPr>
-        <p:spPr>
-          <a:xfrm>
-            <a:off x="-2" y="2656114"/>
-            <a:ext cx="3719479" cy="1230858"/>
-          </a:xfrm>
-          <a:prstGeom prst="roundRect">
-            <a:avLst/>
-          </a:prstGeom>
-          <a:solidFill>
-            <a:srgbClr val="F17FB1"/>
-          </a:solidFill>
-        </p:spPr>
-        <p:style>
-          <a:lnRef idx="2">
-            <a:schemeClr val="accent1">
-              <a:shade val="15000"/>
-            </a:schemeClr>
-          </a:lnRef>
-          <a:fillRef idx="1">
-            <a:schemeClr val="accent1"/>
-          </a:fillRef>
-          <a:effectRef idx="0">
-            <a:schemeClr val="accent1"/>
-          </a:effectRef>
-          <a:fontRef idx="minor">
-            <a:schemeClr val="lt1"/>
-          </a:fontRef>
-        </p:style>
-        <p:txBody>
-          <a:bodyPr rtlCol="0" anchor="ctr"/>
-          <a:lstStyle/>
-          <a:p>
-            <a:pPr algn="ctr"/>
-            <a:r>
-              <a:rPr lang="en-US" sz="6600" dirty="0">
-                <a:latin typeface="Arial" panose="020B0604020202020204" pitchFamily="34" charset="0"/>
-                <a:cs typeface="Arial" panose="020B0604020202020204" pitchFamily="34" charset="0"/>
-              </a:rPr>
-              <a:t>Werribee</a:t>
-            </a:r>
-          </a:p>
-        </p:txBody>
-      </p:sp>
-    </p:spTree>
-    <p:extLst>
-      <p:ext uri="{BB962C8B-B14F-4D97-AF65-F5344CB8AC3E}">
-        <p14:creationId xmlns:p14="http://schemas.microsoft.com/office/powerpoint/2010/main" val="581619592"/>
-      </p:ext>
-    </p:extLst>
-  </p:cSld>
-  <p:clrMapOvr>
-    <a:masterClrMapping/>
-  </p:clrMapOvr>
-</p:sld>
-</file>
-
-<file path=ppt/slides/slide13.xml><?xml version="1.0" encoding="utf-8"?>
+<file path=ppt/slides/slide11.xml><?xml version="1.0" encoding="utf-8"?>
 <p:sld xmlns:a="http://schemas.openxmlformats.org/drawingml/2006/main" xmlns:r="http://schemas.openxmlformats.org/officeDocument/2006/relationships" xmlns:p="http://schemas.openxmlformats.org/presentationml/2006/main">
   <p:cSld>
     <p:spTree>
@@ -3778,7 +3594,7 @@
 </p:sld>
 </file>
 
-<file path=ppt/slides/slide14.xml><?xml version="1.0" encoding="utf-8"?>
+<file path=ppt/slides/slide12.xml><?xml version="1.0" encoding="utf-8"?>
 <p:sld xmlns:a="http://schemas.openxmlformats.org/drawingml/2006/main" xmlns:r="http://schemas.openxmlformats.org/officeDocument/2006/relationships" xmlns:p="http://schemas.openxmlformats.org/presentationml/2006/main">
   <p:cSld>
     <p:spTree>
@@ -3873,7 +3689,7 @@
 </p:sld>
 </file>
 
-<file path=ppt/slides/slide15.xml><?xml version="1.0" encoding="utf-8"?>
+<file path=ppt/slides/slide13.xml><?xml version="1.0" encoding="utf-8"?>
 <p:sld xmlns:a="http://schemas.openxmlformats.org/drawingml/2006/main" xmlns:r="http://schemas.openxmlformats.org/officeDocument/2006/relationships" xmlns:p="http://schemas.openxmlformats.org/presentationml/2006/main">
   <p:cSld>
     <p:spTree>
@@ -3964,7 +3780,7 @@
 </p:sld>
 </file>
 
-<file path=ppt/slides/slide16.xml><?xml version="1.0" encoding="utf-8"?>
+<file path=ppt/slides/slide14.xml><?xml version="1.0" encoding="utf-8"?>
 <p:sld xmlns:a="http://schemas.openxmlformats.org/drawingml/2006/main" xmlns:r="http://schemas.openxmlformats.org/officeDocument/2006/relationships" xmlns:p="http://schemas.openxmlformats.org/presentationml/2006/main">
   <p:cSld>
     <p:spTree>
@@ -4055,7 +3871,7 @@
 </p:sld>
 </file>
 
-<file path=ppt/slides/slide17.xml><?xml version="1.0" encoding="utf-8"?>
+<file path=ppt/slides/slide15.xml><?xml version="1.0" encoding="utf-8"?>
 <p:sld xmlns:a="http://schemas.openxmlformats.org/drawingml/2006/main" xmlns:r="http://schemas.openxmlformats.org/officeDocument/2006/relationships" xmlns:p="http://schemas.openxmlformats.org/presentationml/2006/main">
   <p:cSld>
     <p:spTree>
@@ -4146,7 +3962,7 @@
 </p:sld>
 </file>
 
-<file path=ppt/slides/slide18.xml><?xml version="1.0" encoding="utf-8"?>
+<file path=ppt/slides/slide16.xml><?xml version="1.0" encoding="utf-8"?>
 <p:sld xmlns:a="http://schemas.openxmlformats.org/drawingml/2006/main" xmlns:r="http://schemas.openxmlformats.org/officeDocument/2006/relationships" xmlns:p="http://schemas.openxmlformats.org/presentationml/2006/main">
   <p:cSld>
     <p:spTree>
@@ -4241,7 +4057,7 @@
 </p:sld>
 </file>
 
-<file path=ppt/slides/slide19.xml><?xml version="1.0" encoding="utf-8"?>
+<file path=ppt/slides/slide17.xml><?xml version="1.0" encoding="utf-8"?>
 <p:sld xmlns:a="http://schemas.openxmlformats.org/drawingml/2006/main" xmlns:r="http://schemas.openxmlformats.org/officeDocument/2006/relationships" xmlns:p="http://schemas.openxmlformats.org/presentationml/2006/main" showMasterSp="0">
   <p:cSld>
     <p:bg>
@@ -4342,6 +4158,188 @@
 </p:sld>
 </file>
 
+<file path=ppt/slides/slide18.xml><?xml version="1.0" encoding="utf-8"?>
+<p:sld xmlns:a="http://schemas.openxmlformats.org/drawingml/2006/main" xmlns:r="http://schemas.openxmlformats.org/officeDocument/2006/relationships" xmlns:p="http://schemas.openxmlformats.org/presentationml/2006/main">
+  <p:cSld>
+    <p:spTree>
+      <p:nvGrpSpPr>
+        <p:cNvPr id="1" name="">
+          <a:extLst>
+            <a:ext uri="{FF2B5EF4-FFF2-40B4-BE49-F238E27FC236}">
+              <a16:creationId xmlns:a16="http://schemas.microsoft.com/office/drawing/2014/main" id="{61346427-31FF-5622-7BD1-093A5AB4515D}"/>
+            </a:ext>
+          </a:extLst>
+        </p:cNvPr>
+        <p:cNvGrpSpPr/>
+        <p:nvPr/>
+      </p:nvGrpSpPr>
+      <p:grpSpPr>
+        <a:xfrm>
+          <a:off x="0" y="0"/>
+          <a:ext cx="0" cy="0"/>
+          <a:chOff x="0" y="0"/>
+          <a:chExt cx="0" cy="0"/>
+        </a:xfrm>
+      </p:grpSpPr>
+      <p:sp>
+        <p:nvSpPr>
+          <p:cNvPr id="2" name="Rectangle: Rounded Corners 1">
+            <a:extLst>
+              <a:ext uri="{FF2B5EF4-FFF2-40B4-BE49-F238E27FC236}">
+                <a16:creationId xmlns:a16="http://schemas.microsoft.com/office/drawing/2014/main" id="{BA24CA3A-6529-5CC4-A29D-8FB44338E614}"/>
+              </a:ext>
+            </a:extLst>
+          </p:cNvPr>
+          <p:cNvSpPr/>
+          <p:nvPr/>
+        </p:nvSpPr>
+        <p:spPr>
+          <a:xfrm>
+            <a:off x="-1" y="1328057"/>
+            <a:ext cx="3458221" cy="1230858"/>
+          </a:xfrm>
+          <a:prstGeom prst="roundRect">
+            <a:avLst/>
+          </a:prstGeom>
+          <a:solidFill>
+            <a:srgbClr val="00A8E4"/>
+          </a:solidFill>
+        </p:spPr>
+        <p:style>
+          <a:lnRef idx="2">
+            <a:schemeClr val="accent1">
+              <a:shade val="15000"/>
+            </a:schemeClr>
+          </a:lnRef>
+          <a:fillRef idx="1">
+            <a:schemeClr val="accent1"/>
+          </a:fillRef>
+          <a:effectRef idx="0">
+            <a:schemeClr val="accent1"/>
+          </a:effectRef>
+          <a:fontRef idx="minor">
+            <a:schemeClr val="lt1"/>
+          </a:fontRef>
+        </p:style>
+        <p:txBody>
+          <a:bodyPr rtlCol="0" anchor="ctr"/>
+          <a:lstStyle/>
+          <a:p>
+            <a:pPr algn="ctr"/>
+            <a:r>
+              <a:rPr lang="en-US" sz="6600" dirty="0">
+                <a:latin typeface="Arial" panose="020B0604020202020204" pitchFamily="34" charset="0"/>
+                <a:cs typeface="Arial" panose="020B0604020202020204" pitchFamily="34" charset="0"/>
+              </a:rPr>
+              <a:t>Sunbury</a:t>
+            </a:r>
+          </a:p>
+        </p:txBody>
+      </p:sp>
+    </p:spTree>
+    <p:extLst>
+      <p:ext uri="{BB962C8B-B14F-4D97-AF65-F5344CB8AC3E}">
+        <p14:creationId xmlns:p14="http://schemas.microsoft.com/office/powerpoint/2010/main" val="2803663163"/>
+      </p:ext>
+    </p:extLst>
+  </p:cSld>
+  <p:clrMapOvr>
+    <a:masterClrMapping/>
+  </p:clrMapOvr>
+</p:sld>
+</file>
+
+<file path=ppt/slides/slide19.xml><?xml version="1.0" encoding="utf-8"?>
+<p:sld xmlns:a="http://schemas.openxmlformats.org/drawingml/2006/main" xmlns:r="http://schemas.openxmlformats.org/officeDocument/2006/relationships" xmlns:p="http://schemas.openxmlformats.org/presentationml/2006/main">
+  <p:cSld>
+    <p:spTree>
+      <p:nvGrpSpPr>
+        <p:cNvPr id="1" name="">
+          <a:extLst>
+            <a:ext uri="{FF2B5EF4-FFF2-40B4-BE49-F238E27FC236}">
+              <a16:creationId xmlns:a16="http://schemas.microsoft.com/office/drawing/2014/main" id="{FF41AFF3-76F0-56F8-2232-9132B4C968E6}"/>
+            </a:ext>
+          </a:extLst>
+        </p:cNvPr>
+        <p:cNvGrpSpPr/>
+        <p:nvPr/>
+      </p:nvGrpSpPr>
+      <p:grpSpPr>
+        <a:xfrm>
+          <a:off x="0" y="0"/>
+          <a:ext cx="0" cy="0"/>
+          <a:chOff x="0" y="0"/>
+          <a:chExt cx="0" cy="0"/>
+        </a:xfrm>
+      </p:grpSpPr>
+      <p:sp>
+        <p:nvSpPr>
+          <p:cNvPr id="2" name="Rectangle: Rounded Corners 1">
+            <a:extLst>
+              <a:ext uri="{FF2B5EF4-FFF2-40B4-BE49-F238E27FC236}">
+                <a16:creationId xmlns:a16="http://schemas.microsoft.com/office/drawing/2014/main" id="{590DB49A-20DC-C4B6-9EED-9884FEAD49EE}"/>
+              </a:ext>
+            </a:extLst>
+          </p:cNvPr>
+          <p:cNvSpPr/>
+          <p:nvPr/>
+        </p:nvSpPr>
+        <p:spPr>
+          <a:xfrm>
+            <a:off x="-1" y="1328057"/>
+            <a:ext cx="4186519" cy="1230858"/>
+          </a:xfrm>
+          <a:prstGeom prst="roundRect">
+            <a:avLst/>
+          </a:prstGeom>
+          <a:solidFill>
+            <a:schemeClr val="tx1"/>
+          </a:solidFill>
+        </p:spPr>
+        <p:style>
+          <a:lnRef idx="2">
+            <a:schemeClr val="accent1">
+              <a:shade val="15000"/>
+            </a:schemeClr>
+          </a:lnRef>
+          <a:fillRef idx="1">
+            <a:schemeClr val="accent1"/>
+          </a:fillRef>
+          <a:effectRef idx="0">
+            <a:schemeClr val="accent1"/>
+          </a:effectRef>
+          <a:fontRef idx="minor">
+            <a:schemeClr val="lt1"/>
+          </a:fontRef>
+        </p:style>
+        <p:txBody>
+          <a:bodyPr rtlCol="0" anchor="ctr"/>
+          <a:lstStyle/>
+          <a:p>
+            <a:pPr algn="ctr"/>
+            <a:r>
+              <a:rPr lang="en-US" sz="6600" dirty="0">
+                <a:latin typeface="Arial" panose="020B0604020202020204" pitchFamily="34" charset="0"/>
+                <a:cs typeface="Arial" panose="020B0604020202020204" pitchFamily="34" charset="0"/>
+              </a:rPr>
+              <a:t>City Circle</a:t>
+            </a:r>
+          </a:p>
+        </p:txBody>
+      </p:sp>
+    </p:spTree>
+    <p:extLst>
+      <p:ext uri="{BB962C8B-B14F-4D97-AF65-F5344CB8AC3E}">
+        <p14:creationId xmlns:p14="http://schemas.microsoft.com/office/powerpoint/2010/main" val="3488651827"/>
+      </p:ext>
+    </p:extLst>
+  </p:cSld>
+  <p:clrMapOvr>
+    <a:masterClrMapping/>
+  </p:clrMapOvr>
+</p:sld>
+</file>
+
 <file path=ppt/slides/slide2.xml><?xml version="1.0" encoding="utf-8"?>
 <p:sld xmlns:a="http://schemas.openxmlformats.org/drawingml/2006/main" xmlns:r="http://schemas.openxmlformats.org/officeDocument/2006/relationships" xmlns:p="http://schemas.openxmlformats.org/presentationml/2006/main">
   <p:cSld>
@@ -4424,188 +4422,6 @@
     <p:extLst>
       <p:ext uri="{BB962C8B-B14F-4D97-AF65-F5344CB8AC3E}">
         <p14:creationId xmlns:p14="http://schemas.microsoft.com/office/powerpoint/2010/main" val="1129601660"/>
-      </p:ext>
-    </p:extLst>
-  </p:cSld>
-  <p:clrMapOvr>
-    <a:masterClrMapping/>
-  </p:clrMapOvr>
-</p:sld>
-</file>
-
-<file path=ppt/slides/slide20.xml><?xml version="1.0" encoding="utf-8"?>
-<p:sld xmlns:a="http://schemas.openxmlformats.org/drawingml/2006/main" xmlns:r="http://schemas.openxmlformats.org/officeDocument/2006/relationships" xmlns:p="http://schemas.openxmlformats.org/presentationml/2006/main">
-  <p:cSld>
-    <p:spTree>
-      <p:nvGrpSpPr>
-        <p:cNvPr id="1" name="">
-          <a:extLst>
-            <a:ext uri="{FF2B5EF4-FFF2-40B4-BE49-F238E27FC236}">
-              <a16:creationId xmlns:a16="http://schemas.microsoft.com/office/drawing/2014/main" id="{61346427-31FF-5622-7BD1-093A5AB4515D}"/>
-            </a:ext>
-          </a:extLst>
-        </p:cNvPr>
-        <p:cNvGrpSpPr/>
-        <p:nvPr/>
-      </p:nvGrpSpPr>
-      <p:grpSpPr>
-        <a:xfrm>
-          <a:off x="0" y="0"/>
-          <a:ext cx="0" cy="0"/>
-          <a:chOff x="0" y="0"/>
-          <a:chExt cx="0" cy="0"/>
-        </a:xfrm>
-      </p:grpSpPr>
-      <p:sp>
-        <p:nvSpPr>
-          <p:cNvPr id="2" name="Rectangle: Rounded Corners 1">
-            <a:extLst>
-              <a:ext uri="{FF2B5EF4-FFF2-40B4-BE49-F238E27FC236}">
-                <a16:creationId xmlns:a16="http://schemas.microsoft.com/office/drawing/2014/main" id="{BA24CA3A-6529-5CC4-A29D-8FB44338E614}"/>
-              </a:ext>
-            </a:extLst>
-          </p:cNvPr>
-          <p:cNvSpPr/>
-          <p:nvPr/>
-        </p:nvSpPr>
-        <p:spPr>
-          <a:xfrm>
-            <a:off x="-1" y="1328057"/>
-            <a:ext cx="3458221" cy="1230858"/>
-          </a:xfrm>
-          <a:prstGeom prst="roundRect">
-            <a:avLst/>
-          </a:prstGeom>
-          <a:solidFill>
-            <a:srgbClr val="00A8E4"/>
-          </a:solidFill>
-        </p:spPr>
-        <p:style>
-          <a:lnRef idx="2">
-            <a:schemeClr val="accent1">
-              <a:shade val="15000"/>
-            </a:schemeClr>
-          </a:lnRef>
-          <a:fillRef idx="1">
-            <a:schemeClr val="accent1"/>
-          </a:fillRef>
-          <a:effectRef idx="0">
-            <a:schemeClr val="accent1"/>
-          </a:effectRef>
-          <a:fontRef idx="minor">
-            <a:schemeClr val="lt1"/>
-          </a:fontRef>
-        </p:style>
-        <p:txBody>
-          <a:bodyPr rtlCol="0" anchor="ctr"/>
-          <a:lstStyle/>
-          <a:p>
-            <a:pPr algn="ctr"/>
-            <a:r>
-              <a:rPr lang="en-US" sz="6600" dirty="0">
-                <a:latin typeface="Arial" panose="020B0604020202020204" pitchFamily="34" charset="0"/>
-                <a:cs typeface="Arial" panose="020B0604020202020204" pitchFamily="34" charset="0"/>
-              </a:rPr>
-              <a:t>Sunbury</a:t>
-            </a:r>
-          </a:p>
-        </p:txBody>
-      </p:sp>
-    </p:spTree>
-    <p:extLst>
-      <p:ext uri="{BB962C8B-B14F-4D97-AF65-F5344CB8AC3E}">
-        <p14:creationId xmlns:p14="http://schemas.microsoft.com/office/powerpoint/2010/main" val="2803663163"/>
-      </p:ext>
-    </p:extLst>
-  </p:cSld>
-  <p:clrMapOvr>
-    <a:masterClrMapping/>
-  </p:clrMapOvr>
-</p:sld>
-</file>
-
-<file path=ppt/slides/slide21.xml><?xml version="1.0" encoding="utf-8"?>
-<p:sld xmlns:a="http://schemas.openxmlformats.org/drawingml/2006/main" xmlns:r="http://schemas.openxmlformats.org/officeDocument/2006/relationships" xmlns:p="http://schemas.openxmlformats.org/presentationml/2006/main">
-  <p:cSld>
-    <p:spTree>
-      <p:nvGrpSpPr>
-        <p:cNvPr id="1" name="">
-          <a:extLst>
-            <a:ext uri="{FF2B5EF4-FFF2-40B4-BE49-F238E27FC236}">
-              <a16:creationId xmlns:a16="http://schemas.microsoft.com/office/drawing/2014/main" id="{FF41AFF3-76F0-56F8-2232-9132B4C968E6}"/>
-            </a:ext>
-          </a:extLst>
-        </p:cNvPr>
-        <p:cNvGrpSpPr/>
-        <p:nvPr/>
-      </p:nvGrpSpPr>
-      <p:grpSpPr>
-        <a:xfrm>
-          <a:off x="0" y="0"/>
-          <a:ext cx="0" cy="0"/>
-          <a:chOff x="0" y="0"/>
-          <a:chExt cx="0" cy="0"/>
-        </a:xfrm>
-      </p:grpSpPr>
-      <p:sp>
-        <p:nvSpPr>
-          <p:cNvPr id="2" name="Rectangle: Rounded Corners 1">
-            <a:extLst>
-              <a:ext uri="{FF2B5EF4-FFF2-40B4-BE49-F238E27FC236}">
-                <a16:creationId xmlns:a16="http://schemas.microsoft.com/office/drawing/2014/main" id="{590DB49A-20DC-C4B6-9EED-9884FEAD49EE}"/>
-              </a:ext>
-            </a:extLst>
-          </p:cNvPr>
-          <p:cNvSpPr/>
-          <p:nvPr/>
-        </p:nvSpPr>
-        <p:spPr>
-          <a:xfrm>
-            <a:off x="-1" y="1328057"/>
-            <a:ext cx="4186519" cy="1230858"/>
-          </a:xfrm>
-          <a:prstGeom prst="roundRect">
-            <a:avLst/>
-          </a:prstGeom>
-          <a:solidFill>
-            <a:schemeClr val="tx1"/>
-          </a:solidFill>
-        </p:spPr>
-        <p:style>
-          <a:lnRef idx="2">
-            <a:schemeClr val="accent1">
-              <a:shade val="15000"/>
-            </a:schemeClr>
-          </a:lnRef>
-          <a:fillRef idx="1">
-            <a:schemeClr val="accent1"/>
-          </a:fillRef>
-          <a:effectRef idx="0">
-            <a:schemeClr val="accent1"/>
-          </a:effectRef>
-          <a:fontRef idx="minor">
-            <a:schemeClr val="lt1"/>
-          </a:fontRef>
-        </p:style>
-        <p:txBody>
-          <a:bodyPr rtlCol="0" anchor="ctr"/>
-          <a:lstStyle/>
-          <a:p>
-            <a:pPr algn="ctr"/>
-            <a:r>
-              <a:rPr lang="en-US" sz="6600" dirty="0">
-                <a:latin typeface="Arial" panose="020B0604020202020204" pitchFamily="34" charset="0"/>
-                <a:cs typeface="Arial" panose="020B0604020202020204" pitchFamily="34" charset="0"/>
-              </a:rPr>
-              <a:t>City Circle</a:t>
-            </a:r>
-          </a:p>
-        </p:txBody>
-      </p:sp>
-    </p:spTree>
-    <p:extLst>
-      <p:ext uri="{BB962C8B-B14F-4D97-AF65-F5344CB8AC3E}">
-        <p14:creationId xmlns:p14="http://schemas.microsoft.com/office/powerpoint/2010/main" val="3488651827"/>
       </p:ext>
     </p:extLst>
   </p:cSld>

</xml_diff>

<commit_message>
Revert "Merge pull request #109 from TrackPulse-Vic/master"
This reverts commit 77f50cfbe6dd1c33acc02f69994a0d2eac76bd7a, reversing
changes made to a34f4a40d1745bdd0db97902346977d6d833bbe9.
</commit_message>
<xml_diff>
--- a/lines.pptx
+++ b/lines.pptx
@@ -14,16 +14,18 @@
     <p:sldId id="265" r:id="rId8"/>
     <p:sldId id="258" r:id="rId9"/>
     <p:sldId id="266" r:id="rId10"/>
-    <p:sldId id="267" r:id="rId11"/>
-    <p:sldId id="268" r:id="rId12"/>
-    <p:sldId id="259" r:id="rId13"/>
-    <p:sldId id="269" r:id="rId14"/>
-    <p:sldId id="270" r:id="rId15"/>
-    <p:sldId id="271" r:id="rId16"/>
-    <p:sldId id="272" r:id="rId17"/>
-    <p:sldId id="260" r:id="rId18"/>
-    <p:sldId id="273" r:id="rId19"/>
-    <p:sldId id="274" r:id="rId20"/>
+    <p:sldId id="275" r:id="rId11"/>
+    <p:sldId id="267" r:id="rId12"/>
+    <p:sldId id="276" r:id="rId13"/>
+    <p:sldId id="268" r:id="rId14"/>
+    <p:sldId id="259" r:id="rId15"/>
+    <p:sldId id="269" r:id="rId16"/>
+    <p:sldId id="270" r:id="rId17"/>
+    <p:sldId id="271" r:id="rId18"/>
+    <p:sldId id="272" r:id="rId19"/>
+    <p:sldId id="260" r:id="rId20"/>
+    <p:sldId id="273" r:id="rId21"/>
+    <p:sldId id="274" r:id="rId22"/>
   </p:sldIdLst>
   <p:sldSz cx="12192000" cy="6858000"/>
   <p:notesSz cx="6858000" cy="9144000"/>
@@ -277,7 +279,7 @@
           <a:p>
             <a:fld id="{6CD1D8C8-0B81-4867-BF7F-A4563C3E5BB4}" type="datetimeFigureOut">
               <a:rPr lang="en-US" smtClean="0"/>
-              <a:t>2024-10-27</a:t>
+              <a:t>1/28/2026</a:t>
             </a:fld>
             <a:endParaRPr lang="en-US"/>
           </a:p>
@@ -475,7 +477,7 @@
           <a:p>
             <a:fld id="{6CD1D8C8-0B81-4867-BF7F-A4563C3E5BB4}" type="datetimeFigureOut">
               <a:rPr lang="en-US" smtClean="0"/>
-              <a:t>2024-10-27</a:t>
+              <a:t>1/28/2026</a:t>
             </a:fld>
             <a:endParaRPr lang="en-US"/>
           </a:p>
@@ -683,7 +685,7 @@
           <a:p>
             <a:fld id="{6CD1D8C8-0B81-4867-BF7F-A4563C3E5BB4}" type="datetimeFigureOut">
               <a:rPr lang="en-US" smtClean="0"/>
-              <a:t>2024-10-27</a:t>
+              <a:t>1/28/2026</a:t>
             </a:fld>
             <a:endParaRPr lang="en-US"/>
           </a:p>
@@ -881,7 +883,7 @@
           <a:p>
             <a:fld id="{6CD1D8C8-0B81-4867-BF7F-A4563C3E5BB4}" type="datetimeFigureOut">
               <a:rPr lang="en-US" smtClean="0"/>
-              <a:t>2024-10-27</a:t>
+              <a:t>1/28/2026</a:t>
             </a:fld>
             <a:endParaRPr lang="en-US"/>
           </a:p>
@@ -1156,7 +1158,7 @@
           <a:p>
             <a:fld id="{6CD1D8C8-0B81-4867-BF7F-A4563C3E5BB4}" type="datetimeFigureOut">
               <a:rPr lang="en-US" smtClean="0"/>
-              <a:t>2024-10-27</a:t>
+              <a:t>1/28/2026</a:t>
             </a:fld>
             <a:endParaRPr lang="en-US"/>
           </a:p>
@@ -1421,7 +1423,7 @@
           <a:p>
             <a:fld id="{6CD1D8C8-0B81-4867-BF7F-A4563C3E5BB4}" type="datetimeFigureOut">
               <a:rPr lang="en-US" smtClean="0"/>
-              <a:t>2024-10-27</a:t>
+              <a:t>1/28/2026</a:t>
             </a:fld>
             <a:endParaRPr lang="en-US"/>
           </a:p>
@@ -1833,7 +1835,7 @@
           <a:p>
             <a:fld id="{6CD1D8C8-0B81-4867-BF7F-A4563C3E5BB4}" type="datetimeFigureOut">
               <a:rPr lang="en-US" smtClean="0"/>
-              <a:t>2024-10-27</a:t>
+              <a:t>1/28/2026</a:t>
             </a:fld>
             <a:endParaRPr lang="en-US"/>
           </a:p>
@@ -1974,7 +1976,7 @@
           <a:p>
             <a:fld id="{6CD1D8C8-0B81-4867-BF7F-A4563C3E5BB4}" type="datetimeFigureOut">
               <a:rPr lang="en-US" smtClean="0"/>
-              <a:t>2024-10-27</a:t>
+              <a:t>1/28/2026</a:t>
             </a:fld>
             <a:endParaRPr lang="en-US"/>
           </a:p>
@@ -2087,7 +2089,7 @@
           <a:p>
             <a:fld id="{6CD1D8C8-0B81-4867-BF7F-A4563C3E5BB4}" type="datetimeFigureOut">
               <a:rPr lang="en-US" smtClean="0"/>
-              <a:t>2024-10-27</a:t>
+              <a:t>1/28/2026</a:t>
             </a:fld>
             <a:endParaRPr lang="en-US"/>
           </a:p>
@@ -2398,7 +2400,7 @@
           <a:p>
             <a:fld id="{6CD1D8C8-0B81-4867-BF7F-A4563C3E5BB4}" type="datetimeFigureOut">
               <a:rPr lang="en-US" smtClean="0"/>
-              <a:t>2024-10-27</a:t>
+              <a:t>1/28/2026</a:t>
             </a:fld>
             <a:endParaRPr lang="en-US"/>
           </a:p>
@@ -2686,7 +2688,7 @@
           <a:p>
             <a:fld id="{6CD1D8C8-0B81-4867-BF7F-A4563C3E5BB4}" type="datetimeFigureOut">
               <a:rPr lang="en-US" smtClean="0"/>
-              <a:t>2024-10-27</a:t>
+              <a:t>1/28/2026</a:t>
             </a:fld>
             <a:endParaRPr lang="en-US"/>
           </a:p>
@@ -2927,7 +2929,7 @@
           <a:p>
             <a:fld id="{6CD1D8C8-0B81-4867-BF7F-A4563C3E5BB4}" type="datetimeFigureOut">
               <a:rPr lang="en-US" smtClean="0"/>
-              <a:t>2024-10-27</a:t>
+              <a:t>1/28/2026</a:t>
             </a:fld>
             <a:endParaRPr lang="en-US"/>
           </a:p>
@@ -3420,6 +3422,97 @@
         <p:cNvPr id="1" name="">
           <a:extLst>
             <a:ext uri="{FF2B5EF4-FFF2-40B4-BE49-F238E27FC236}">
+              <a16:creationId xmlns:a16="http://schemas.microsoft.com/office/drawing/2014/main" id="{AB894BDB-E362-0D07-402E-3412EAB0C94F}"/>
+            </a:ext>
+          </a:extLst>
+        </p:cNvPr>
+        <p:cNvGrpSpPr/>
+        <p:nvPr/>
+      </p:nvGrpSpPr>
+      <p:grpSpPr>
+        <a:xfrm>
+          <a:off x="0" y="0"/>
+          <a:ext cx="0" cy="0"/>
+          <a:chOff x="0" y="0"/>
+          <a:chExt cx="0" cy="0"/>
+        </a:xfrm>
+      </p:grpSpPr>
+      <p:sp>
+        <p:nvSpPr>
+          <p:cNvPr id="2" name="Rectangle: Rounded Corners 1">
+            <a:extLst>
+              <a:ext uri="{FF2B5EF4-FFF2-40B4-BE49-F238E27FC236}">
+                <a16:creationId xmlns:a16="http://schemas.microsoft.com/office/drawing/2014/main" id="{EC6702DC-3BAB-D408-15F2-0EE2B680BC0F}"/>
+              </a:ext>
+            </a:extLst>
+          </p:cNvPr>
+          <p:cNvSpPr/>
+          <p:nvPr/>
+        </p:nvSpPr>
+        <p:spPr>
+          <a:xfrm>
+            <a:off x="-1" y="1328057"/>
+            <a:ext cx="5252645" cy="1230858"/>
+          </a:xfrm>
+          <a:prstGeom prst="roundRect">
+            <a:avLst/>
+          </a:prstGeom>
+          <a:solidFill>
+            <a:srgbClr val="F17FB1"/>
+          </a:solidFill>
+        </p:spPr>
+        <p:style>
+          <a:lnRef idx="2">
+            <a:schemeClr val="accent1">
+              <a:shade val="15000"/>
+            </a:schemeClr>
+          </a:lnRef>
+          <a:fillRef idx="1">
+            <a:schemeClr val="accent1"/>
+          </a:fillRef>
+          <a:effectRef idx="0">
+            <a:schemeClr val="accent1"/>
+          </a:effectRef>
+          <a:fontRef idx="minor">
+            <a:schemeClr val="lt1"/>
+          </a:fontRef>
+        </p:style>
+        <p:txBody>
+          <a:bodyPr rtlCol="0" anchor="ctr"/>
+          <a:lstStyle/>
+          <a:p>
+            <a:pPr algn="ctr"/>
+            <a:r>
+              <a:rPr lang="en-US" sz="6600" dirty="0">
+                <a:latin typeface="Arial" panose="020B0604020202020204" pitchFamily="34" charset="0"/>
+                <a:cs typeface="Arial" panose="020B0604020202020204" pitchFamily="34" charset="0"/>
+              </a:rPr>
+              <a:t>Williamstown</a:t>
+            </a:r>
+          </a:p>
+        </p:txBody>
+      </p:sp>
+    </p:spTree>
+    <p:extLst>
+      <p:ext uri="{BB962C8B-B14F-4D97-AF65-F5344CB8AC3E}">
+        <p14:creationId xmlns:p14="http://schemas.microsoft.com/office/powerpoint/2010/main" val="635404039"/>
+      </p:ext>
+    </p:extLst>
+  </p:cSld>
+  <p:clrMapOvr>
+    <a:masterClrMapping/>
+  </p:clrMapOvr>
+</p:sld>
+</file>
+
+<file path=ppt/slides/slide11.xml><?xml version="1.0" encoding="utf-8"?>
+<p:sld xmlns:a="http://schemas.openxmlformats.org/drawingml/2006/main" xmlns:r="http://schemas.openxmlformats.org/officeDocument/2006/relationships" xmlns:p="http://schemas.openxmlformats.org/presentationml/2006/main">
+  <p:cSld>
+    <p:spTree>
+      <p:nvGrpSpPr>
+        <p:cNvPr id="1" name="">
+          <a:extLst>
+            <a:ext uri="{FF2B5EF4-FFF2-40B4-BE49-F238E27FC236}">
               <a16:creationId xmlns:a16="http://schemas.microsoft.com/office/drawing/2014/main" id="{671DEDE4-7D57-1609-0683-D8B542899E62}"/>
             </a:ext>
           </a:extLst>
@@ -3503,7 +3596,98 @@
 </p:sld>
 </file>
 
-<file path=ppt/slides/slide11.xml><?xml version="1.0" encoding="utf-8"?>
+<file path=ppt/slides/slide12.xml><?xml version="1.0" encoding="utf-8"?>
+<p:sld xmlns:a="http://schemas.openxmlformats.org/drawingml/2006/main" xmlns:r="http://schemas.openxmlformats.org/officeDocument/2006/relationships" xmlns:p="http://schemas.openxmlformats.org/presentationml/2006/main">
+  <p:cSld>
+    <p:spTree>
+      <p:nvGrpSpPr>
+        <p:cNvPr id="1" name="">
+          <a:extLst>
+            <a:ext uri="{FF2B5EF4-FFF2-40B4-BE49-F238E27FC236}">
+              <a16:creationId xmlns:a16="http://schemas.microsoft.com/office/drawing/2014/main" id="{36ECA3D9-56B3-5CD5-423E-D5B3B5A7C7B3}"/>
+            </a:ext>
+          </a:extLst>
+        </p:cNvPr>
+        <p:cNvGrpSpPr/>
+        <p:nvPr/>
+      </p:nvGrpSpPr>
+      <p:grpSpPr>
+        <a:xfrm>
+          <a:off x="0" y="0"/>
+          <a:ext cx="0" cy="0"/>
+          <a:chOff x="0" y="0"/>
+          <a:chExt cx="0" cy="0"/>
+        </a:xfrm>
+      </p:grpSpPr>
+      <p:sp>
+        <p:nvSpPr>
+          <p:cNvPr id="3" name="Rectangle: Rounded Corners 2">
+            <a:extLst>
+              <a:ext uri="{FF2B5EF4-FFF2-40B4-BE49-F238E27FC236}">
+                <a16:creationId xmlns:a16="http://schemas.microsoft.com/office/drawing/2014/main" id="{FF9C5E38-6BBF-89E1-E08D-0DFF56EF9B35}"/>
+              </a:ext>
+            </a:extLst>
+          </p:cNvPr>
+          <p:cNvSpPr/>
+          <p:nvPr/>
+        </p:nvSpPr>
+        <p:spPr>
+          <a:xfrm>
+            <a:off x="-2" y="2656114"/>
+            <a:ext cx="3719479" cy="1230858"/>
+          </a:xfrm>
+          <a:prstGeom prst="roundRect">
+            <a:avLst/>
+          </a:prstGeom>
+          <a:solidFill>
+            <a:srgbClr val="F17FB1"/>
+          </a:solidFill>
+        </p:spPr>
+        <p:style>
+          <a:lnRef idx="2">
+            <a:schemeClr val="accent1">
+              <a:shade val="15000"/>
+            </a:schemeClr>
+          </a:lnRef>
+          <a:fillRef idx="1">
+            <a:schemeClr val="accent1"/>
+          </a:fillRef>
+          <a:effectRef idx="0">
+            <a:schemeClr val="accent1"/>
+          </a:effectRef>
+          <a:fontRef idx="minor">
+            <a:schemeClr val="lt1"/>
+          </a:fontRef>
+        </p:style>
+        <p:txBody>
+          <a:bodyPr rtlCol="0" anchor="ctr"/>
+          <a:lstStyle/>
+          <a:p>
+            <a:pPr algn="ctr"/>
+            <a:r>
+              <a:rPr lang="en-US" sz="6600" dirty="0">
+                <a:latin typeface="Arial" panose="020B0604020202020204" pitchFamily="34" charset="0"/>
+                <a:cs typeface="Arial" panose="020B0604020202020204" pitchFamily="34" charset="0"/>
+              </a:rPr>
+              <a:t>Werribee</a:t>
+            </a:r>
+          </a:p>
+        </p:txBody>
+      </p:sp>
+    </p:spTree>
+    <p:extLst>
+      <p:ext uri="{BB962C8B-B14F-4D97-AF65-F5344CB8AC3E}">
+        <p14:creationId xmlns:p14="http://schemas.microsoft.com/office/powerpoint/2010/main" val="581619592"/>
+      </p:ext>
+    </p:extLst>
+  </p:cSld>
+  <p:clrMapOvr>
+    <a:masterClrMapping/>
+  </p:clrMapOvr>
+</p:sld>
+</file>
+
+<file path=ppt/slides/slide13.xml><?xml version="1.0" encoding="utf-8"?>
 <p:sld xmlns:a="http://schemas.openxmlformats.org/drawingml/2006/main" xmlns:r="http://schemas.openxmlformats.org/officeDocument/2006/relationships" xmlns:p="http://schemas.openxmlformats.org/presentationml/2006/main">
   <p:cSld>
     <p:spTree>
@@ -3594,7 +3778,7 @@
 </p:sld>
 </file>
 
-<file path=ppt/slides/slide12.xml><?xml version="1.0" encoding="utf-8"?>
+<file path=ppt/slides/slide14.xml><?xml version="1.0" encoding="utf-8"?>
 <p:sld xmlns:a="http://schemas.openxmlformats.org/drawingml/2006/main" xmlns:r="http://schemas.openxmlformats.org/officeDocument/2006/relationships" xmlns:p="http://schemas.openxmlformats.org/presentationml/2006/main">
   <p:cSld>
     <p:spTree>
@@ -3689,7 +3873,7 @@
 </p:sld>
 </file>
 
-<file path=ppt/slides/slide13.xml><?xml version="1.0" encoding="utf-8"?>
+<file path=ppt/slides/slide15.xml><?xml version="1.0" encoding="utf-8"?>
 <p:sld xmlns:a="http://schemas.openxmlformats.org/drawingml/2006/main" xmlns:r="http://schemas.openxmlformats.org/officeDocument/2006/relationships" xmlns:p="http://schemas.openxmlformats.org/presentationml/2006/main">
   <p:cSld>
     <p:spTree>
@@ -3780,7 +3964,7 @@
 </p:sld>
 </file>
 
-<file path=ppt/slides/slide14.xml><?xml version="1.0" encoding="utf-8"?>
+<file path=ppt/slides/slide16.xml><?xml version="1.0" encoding="utf-8"?>
 <p:sld xmlns:a="http://schemas.openxmlformats.org/drawingml/2006/main" xmlns:r="http://schemas.openxmlformats.org/officeDocument/2006/relationships" xmlns:p="http://schemas.openxmlformats.org/presentationml/2006/main">
   <p:cSld>
     <p:spTree>
@@ -3871,7 +4055,7 @@
 </p:sld>
 </file>
 
-<file path=ppt/slides/slide15.xml><?xml version="1.0" encoding="utf-8"?>
+<file path=ppt/slides/slide17.xml><?xml version="1.0" encoding="utf-8"?>
 <p:sld xmlns:a="http://schemas.openxmlformats.org/drawingml/2006/main" xmlns:r="http://schemas.openxmlformats.org/officeDocument/2006/relationships" xmlns:p="http://schemas.openxmlformats.org/presentationml/2006/main">
   <p:cSld>
     <p:spTree>
@@ -3962,7 +4146,7 @@
 </p:sld>
 </file>
 
-<file path=ppt/slides/slide16.xml><?xml version="1.0" encoding="utf-8"?>
+<file path=ppt/slides/slide18.xml><?xml version="1.0" encoding="utf-8"?>
 <p:sld xmlns:a="http://schemas.openxmlformats.org/drawingml/2006/main" xmlns:r="http://schemas.openxmlformats.org/officeDocument/2006/relationships" xmlns:p="http://schemas.openxmlformats.org/presentationml/2006/main">
   <p:cSld>
     <p:spTree>
@@ -4057,7 +4241,7 @@
 </p:sld>
 </file>
 
-<file path=ppt/slides/slide17.xml><?xml version="1.0" encoding="utf-8"?>
+<file path=ppt/slides/slide19.xml><?xml version="1.0" encoding="utf-8"?>
 <p:sld xmlns:a="http://schemas.openxmlformats.org/drawingml/2006/main" xmlns:r="http://schemas.openxmlformats.org/officeDocument/2006/relationships" xmlns:p="http://schemas.openxmlformats.org/presentationml/2006/main" showMasterSp="0">
   <p:cSld>
     <p:bg>
@@ -4158,7 +4342,98 @@
 </p:sld>
 </file>
 
-<file path=ppt/slides/slide18.xml><?xml version="1.0" encoding="utf-8"?>
+<file path=ppt/slides/slide2.xml><?xml version="1.0" encoding="utf-8"?>
+<p:sld xmlns:a="http://schemas.openxmlformats.org/drawingml/2006/main" xmlns:r="http://schemas.openxmlformats.org/officeDocument/2006/relationships" xmlns:p="http://schemas.openxmlformats.org/presentationml/2006/main">
+  <p:cSld>
+    <p:spTree>
+      <p:nvGrpSpPr>
+        <p:cNvPr id="1" name="">
+          <a:extLst>
+            <a:ext uri="{FF2B5EF4-FFF2-40B4-BE49-F238E27FC236}">
+              <a16:creationId xmlns:a16="http://schemas.microsoft.com/office/drawing/2014/main" id="{880421E4-1543-8886-7C15-127A6F0848A1}"/>
+            </a:ext>
+          </a:extLst>
+        </p:cNvPr>
+        <p:cNvGrpSpPr/>
+        <p:nvPr/>
+      </p:nvGrpSpPr>
+      <p:grpSpPr>
+        <a:xfrm>
+          <a:off x="0" y="0"/>
+          <a:ext cx="0" cy="0"/>
+          <a:chOff x="0" y="0"/>
+          <a:chExt cx="0" cy="0"/>
+        </a:xfrm>
+      </p:grpSpPr>
+      <p:sp>
+        <p:nvSpPr>
+          <p:cNvPr id="5" name="Rectangle: Rounded Corners 4">
+            <a:extLst>
+              <a:ext uri="{FF2B5EF4-FFF2-40B4-BE49-F238E27FC236}">
+                <a16:creationId xmlns:a16="http://schemas.microsoft.com/office/drawing/2014/main" id="{6BF4E7AB-D02A-CDCE-B638-895666F8ADDE}"/>
+              </a:ext>
+            </a:extLst>
+          </p:cNvPr>
+          <p:cNvSpPr/>
+          <p:nvPr/>
+        </p:nvSpPr>
+        <p:spPr>
+          <a:xfrm>
+            <a:off x="-1" y="1319283"/>
+            <a:ext cx="3636975" cy="1230858"/>
+          </a:xfrm>
+          <a:prstGeom prst="roundRect">
+            <a:avLst/>
+          </a:prstGeom>
+          <a:solidFill>
+            <a:srgbClr val="01518A"/>
+          </a:solidFill>
+        </p:spPr>
+        <p:style>
+          <a:lnRef idx="2">
+            <a:schemeClr val="accent1">
+              <a:shade val="15000"/>
+            </a:schemeClr>
+          </a:lnRef>
+          <a:fillRef idx="1">
+            <a:schemeClr val="accent1"/>
+          </a:fillRef>
+          <a:effectRef idx="0">
+            <a:schemeClr val="accent1"/>
+          </a:effectRef>
+          <a:fontRef idx="minor">
+            <a:schemeClr val="lt1"/>
+          </a:fontRef>
+        </p:style>
+        <p:txBody>
+          <a:bodyPr rtlCol="0" anchor="ctr"/>
+          <a:lstStyle/>
+          <a:p>
+            <a:pPr algn="ctr"/>
+            <a:r>
+              <a:rPr lang="en-US" sz="6600" dirty="0">
+                <a:latin typeface="Arial" panose="020B0604020202020204" pitchFamily="34" charset="0"/>
+                <a:cs typeface="Arial" panose="020B0604020202020204" pitchFamily="34" charset="0"/>
+              </a:rPr>
+              <a:t>Belgrave</a:t>
+            </a:r>
+          </a:p>
+        </p:txBody>
+      </p:sp>
+    </p:spTree>
+    <p:extLst>
+      <p:ext uri="{BB962C8B-B14F-4D97-AF65-F5344CB8AC3E}">
+        <p14:creationId xmlns:p14="http://schemas.microsoft.com/office/powerpoint/2010/main" val="1129601660"/>
+      </p:ext>
+    </p:extLst>
+  </p:cSld>
+  <p:clrMapOvr>
+    <a:masterClrMapping/>
+  </p:clrMapOvr>
+</p:sld>
+</file>
+
+<file path=ppt/slides/slide20.xml><?xml version="1.0" encoding="utf-8"?>
 <p:sld xmlns:a="http://schemas.openxmlformats.org/drawingml/2006/main" xmlns:r="http://schemas.openxmlformats.org/officeDocument/2006/relationships" xmlns:p="http://schemas.openxmlformats.org/presentationml/2006/main">
   <p:cSld>
     <p:spTree>
@@ -4249,7 +4524,7 @@
 </p:sld>
 </file>
 
-<file path=ppt/slides/slide19.xml><?xml version="1.0" encoding="utf-8"?>
+<file path=ppt/slides/slide21.xml><?xml version="1.0" encoding="utf-8"?>
 <p:sld xmlns:a="http://schemas.openxmlformats.org/drawingml/2006/main" xmlns:r="http://schemas.openxmlformats.org/officeDocument/2006/relationships" xmlns:p="http://schemas.openxmlformats.org/presentationml/2006/main">
   <p:cSld>
     <p:spTree>
@@ -4331,97 +4606,6 @@
     <p:extLst>
       <p:ext uri="{BB962C8B-B14F-4D97-AF65-F5344CB8AC3E}">
         <p14:creationId xmlns:p14="http://schemas.microsoft.com/office/powerpoint/2010/main" val="3488651827"/>
-      </p:ext>
-    </p:extLst>
-  </p:cSld>
-  <p:clrMapOvr>
-    <a:masterClrMapping/>
-  </p:clrMapOvr>
-</p:sld>
-</file>
-
-<file path=ppt/slides/slide2.xml><?xml version="1.0" encoding="utf-8"?>
-<p:sld xmlns:a="http://schemas.openxmlformats.org/drawingml/2006/main" xmlns:r="http://schemas.openxmlformats.org/officeDocument/2006/relationships" xmlns:p="http://schemas.openxmlformats.org/presentationml/2006/main">
-  <p:cSld>
-    <p:spTree>
-      <p:nvGrpSpPr>
-        <p:cNvPr id="1" name="">
-          <a:extLst>
-            <a:ext uri="{FF2B5EF4-FFF2-40B4-BE49-F238E27FC236}">
-              <a16:creationId xmlns:a16="http://schemas.microsoft.com/office/drawing/2014/main" id="{880421E4-1543-8886-7C15-127A6F0848A1}"/>
-            </a:ext>
-          </a:extLst>
-        </p:cNvPr>
-        <p:cNvGrpSpPr/>
-        <p:nvPr/>
-      </p:nvGrpSpPr>
-      <p:grpSpPr>
-        <a:xfrm>
-          <a:off x="0" y="0"/>
-          <a:ext cx="0" cy="0"/>
-          <a:chOff x="0" y="0"/>
-          <a:chExt cx="0" cy="0"/>
-        </a:xfrm>
-      </p:grpSpPr>
-      <p:sp>
-        <p:nvSpPr>
-          <p:cNvPr id="5" name="Rectangle: Rounded Corners 4">
-            <a:extLst>
-              <a:ext uri="{FF2B5EF4-FFF2-40B4-BE49-F238E27FC236}">
-                <a16:creationId xmlns:a16="http://schemas.microsoft.com/office/drawing/2014/main" id="{6BF4E7AB-D02A-CDCE-B638-895666F8ADDE}"/>
-              </a:ext>
-            </a:extLst>
-          </p:cNvPr>
-          <p:cNvSpPr/>
-          <p:nvPr/>
-        </p:nvSpPr>
-        <p:spPr>
-          <a:xfrm>
-            <a:off x="-1" y="1319283"/>
-            <a:ext cx="3636975" cy="1230858"/>
-          </a:xfrm>
-          <a:prstGeom prst="roundRect">
-            <a:avLst/>
-          </a:prstGeom>
-          <a:solidFill>
-            <a:srgbClr val="01518A"/>
-          </a:solidFill>
-        </p:spPr>
-        <p:style>
-          <a:lnRef idx="2">
-            <a:schemeClr val="accent1">
-              <a:shade val="15000"/>
-            </a:schemeClr>
-          </a:lnRef>
-          <a:fillRef idx="1">
-            <a:schemeClr val="accent1"/>
-          </a:fillRef>
-          <a:effectRef idx="0">
-            <a:schemeClr val="accent1"/>
-          </a:effectRef>
-          <a:fontRef idx="minor">
-            <a:schemeClr val="lt1"/>
-          </a:fontRef>
-        </p:style>
-        <p:txBody>
-          <a:bodyPr rtlCol="0" anchor="ctr"/>
-          <a:lstStyle/>
-          <a:p>
-            <a:pPr algn="ctr"/>
-            <a:r>
-              <a:rPr lang="en-US" sz="6600" dirty="0">
-                <a:latin typeface="Arial" panose="020B0604020202020204" pitchFamily="34" charset="0"/>
-                <a:cs typeface="Arial" panose="020B0604020202020204" pitchFamily="34" charset="0"/>
-              </a:rPr>
-              <a:t>Belgrave</a:t>
-            </a:r>
-          </a:p>
-        </p:txBody>
-      </p:sp>
-    </p:spTree>
-    <p:extLst>
-      <p:ext uri="{BB962C8B-B14F-4D97-AF65-F5344CB8AC3E}">
-        <p14:creationId xmlns:p14="http://schemas.microsoft.com/office/powerpoint/2010/main" val="1129601660"/>
       </p:ext>
     </p:extLst>
   </p:cSld>

</xml_diff>